<commit_message>
feat: add certificate template and database reset script for development environment
</commit_message>
<xml_diff>
--- a/backend/CERTIFICATE_TEMPLATE.pptx
+++ b/backend/CERTIFICATE_TEMPLATE.pptx
@@ -4018,6 +4018,12 @@
             </a:stretch>
           </a:blipFill>
         </p:spPr>
+        <p:txBody>
+          <a:bodyPr/>
+          <a:p>
+            <a:endParaRPr lang="en-US"/>
+          </a:p>
+        </p:txBody>
       </p:sp>
       <p:sp>
         <p:nvSpPr>

</xml_diff>